<commit_message>
chore: 課程結構從 220 min 壓回 180 min (3 小時)
之前所有 5 段 + 兩個 break 加總是 230 min, 跟實際 3 小時 talk 對不上。
依「保 hands-on 充裕」策略重新切:

| 段 | 舊 | 新 |
|---|----|---|
| Seg 1 Why MCP        | 50 | 40 |
| Seg 2 How MCP Works  | 50 | 40 |
| 休息                  | 10 | 10 |
| Seg 3 Agentic Loop   | 50 | 35 |
| Seg 4 Hands-on       | 50 | 45 |
| Seg 5 Practical      | 10 | 10 |
| 總計                  | 220| 180 ✓ |

更新檔案:
- CLAUDE.md: 課程結構表 + 各段 heading 的 (50 min) → 新時間;
  Seg 4 時間配置從 5×10 重切成 8/10/14/8/5
- docs/index.html: 6 個 timeline-card + 4 個 segment detail duration tag
- 04-hands-on-lab.md: header + 時間配置表 + 講師動向
- tools/build-04-slides.py: cover "50 minutes" → "45 minutes",
  outcomes/schedule slide 時間配置同步
- 04-hands-on-lab.pptx: 重 build (內容變了 8 處)
</commit_message>
<xml_diff>
--- a/04-hands-on-lab.pptx
+++ b/04-hands-on-lab.pptx
@@ -3287,7 +3287,7 @@
                 </a:solidFill>
                 <a:latin typeface="Calibri"/>
               </a:rPr>
-              <a:t>Hands-on Lab  ·  50 minutes</a:t>
+              <a:t>Hands-on Lab  ·  45 minutes</a:t>
             </a:r>
           </a:p>
         </p:txBody>
@@ -7671,7 +7671,7 @@
                 </a:solidFill>
                 <a:latin typeface="Calibri"/>
               </a:rPr>
-              <a:t>50 分鐘後,你將親手擁有</a:t>
+              <a:t>45 分鐘後,你將親手擁有</a:t>
             </a:r>
           </a:p>
         </p:txBody>
@@ -8557,7 +8557,7 @@
                 </a:solidFill>
                 <a:latin typeface="Arial Black"/>
               </a:rPr>
-              <a:t>50 分鐘時間配置</a:t>
+              <a:t>45 分鐘時間配置</a:t>
             </a:r>
           </a:p>
         </p:txBody>
@@ -8592,7 +8592,7 @@
                 </a:solidFill>
                 <a:latin typeface="Calibri"/>
               </a:rPr>
-              <a:t>講師 10 min 引導 + 40 min 巡場陪跑</a:t>
+              <a:t>講師 8 min 引導 + 37 min 巡場陪跑</a:t>
             </a:r>
           </a:p>
         </p:txBody>
@@ -8864,7 +8864,7 @@
                 </a:solidFill>
                 <a:latin typeface="Consolas"/>
               </a:rPr>
-              <a:t>0–10</a:t>
+              <a:t>0–8</a:t>
             </a:r>
           </a:p>
         </p:txBody>
@@ -9013,7 +9013,7 @@
                 </a:solidFill>
                 <a:latin typeface="Consolas"/>
               </a:rPr>
-              <a:t>10–20</a:t>
+              <a:t>8–18</a:t>
             </a:r>
           </a:p>
         </p:txBody>
@@ -9118,7 +9118,7 @@
                 </a:solidFill>
                 <a:latin typeface="Consolas"/>
               </a:rPr>
-              <a:t>20–35</a:t>
+              <a:t>18–32</a:t>
             </a:r>
           </a:p>
         </p:txBody>
@@ -9267,7 +9267,7 @@
                 </a:solidFill>
                 <a:latin typeface="Consolas"/>
               </a:rPr>
-              <a:t>35–45</a:t>
+              <a:t>32–40</a:t>
             </a:r>
           </a:p>
         </p:txBody>
@@ -9372,7 +9372,7 @@
                 </a:solidFill>
                 <a:latin typeface="Consolas"/>
               </a:rPr>
-              <a:t>45–50</a:t>
+              <a:t>40–45</a:t>
             </a:r>
           </a:p>
         </p:txBody>

</xml_diff>